<commit_message>
feat: standalone site wiring — config, parts, docs re-path, examples, diagrams, decks
- _config.yml: docs+parts+examples+plans collections, baseurl /cpp-statelessness
- 7 _parts + part_index layout; 13 docs re-pathed (245 cross-links) + part: front matter
- examples.html + 10 wrappers + READMEs re-pathed to /docs/; main-demo cards dropped
- diagrams.html: 13 compendium diagram cards
- decks: 201 rebuilt (67 slides), new 101 on-ramp (22 slides)
</commit_message>
<xml_diff>
--- a/presentation/cpp-statelessness-compendium.pptx
+++ b/presentation/cpp-statelessness-compendium.pptx
@@ -10917,7 +10917,7 @@
         <p:spPr>
           <a:xfrm>
             <a:off x="6217920" y="1554480"/>
-            <a:ext cx="5486400" cy="2984988"/>
+            <a:ext cx="5486400" cy="2988033"/>
           </a:xfrm>
           <a:prstGeom prst="rect">
             <a:avLst/>
@@ -14512,7 +14512,7 @@
         <p:spPr>
           <a:xfrm>
             <a:off x="6217920" y="1554480"/>
-            <a:ext cx="5486400" cy="2984988"/>
+            <a:ext cx="5486400" cy="2988033"/>
           </a:xfrm>
           <a:prstGeom prst="rect">
             <a:avLst/>
@@ -16440,7 +16440,7 @@
         <p:spPr>
           <a:xfrm>
             <a:off x="6217920" y="1554480"/>
-            <a:ext cx="5486400" cy="2866292"/>
+            <a:ext cx="5486400" cy="2866510"/>
           </a:xfrm>
           <a:prstGeom prst="rect">
             <a:avLst/>
@@ -19096,7 +19096,7 @@
         <p:spPr>
           <a:xfrm>
             <a:off x="6217920" y="1554480"/>
-            <a:ext cx="5486400" cy="2923442"/>
+            <a:ext cx="5486400" cy="2927271"/>
           </a:xfrm>
           <a:prstGeom prst="rect">
             <a:avLst/>
@@ -20997,7 +20997,7 @@
         <p:spPr>
           <a:xfrm>
             <a:off x="6217920" y="1554480"/>
-            <a:ext cx="5486400" cy="2866292"/>
+            <a:ext cx="5486400" cy="2866510"/>
           </a:xfrm>
           <a:prstGeom prst="rect">
             <a:avLst/>
@@ -24337,7 +24337,7 @@
         <p:spPr>
           <a:xfrm>
             <a:off x="6217920" y="1554480"/>
-            <a:ext cx="5486400" cy="2897065"/>
+            <a:ext cx="5486400" cy="2898678"/>
           </a:xfrm>
           <a:prstGeom prst="rect">
             <a:avLst/>
@@ -26043,7 +26043,7 @@
         <p:spPr>
           <a:xfrm>
             <a:off x="6217920" y="1554480"/>
-            <a:ext cx="5486400" cy="2984988"/>
+            <a:ext cx="5486400" cy="2988033"/>
           </a:xfrm>
           <a:prstGeom prst="rect">
             <a:avLst/>
@@ -26459,7 +26459,7 @@
         <p:spPr>
           <a:xfrm>
             <a:off x="6217920" y="1554480"/>
-            <a:ext cx="5486400" cy="2897065"/>
+            <a:ext cx="5486400" cy="2898678"/>
           </a:xfrm>
           <a:prstGeom prst="rect">
             <a:avLst/>
@@ -28573,7 +28573,7 @@
         <p:spPr>
           <a:xfrm>
             <a:off x="6217920" y="1554480"/>
-            <a:ext cx="5486400" cy="2897065"/>
+            <a:ext cx="5486400" cy="2898678"/>
           </a:xfrm>
           <a:prstGeom prst="rect">
             <a:avLst/>
@@ -31309,7 +31309,7 @@
         <p:spPr>
           <a:xfrm>
             <a:off x="6217920" y="1554480"/>
-            <a:ext cx="5486400" cy="2897065"/>
+            <a:ext cx="5486400" cy="2898678"/>
           </a:xfrm>
           <a:prstGeom prst="rect">
             <a:avLst/>
@@ -34055,7 +34055,7 @@
         <p:spPr>
           <a:xfrm>
             <a:off x="6217920" y="1554480"/>
-            <a:ext cx="5486400" cy="2984988"/>
+            <a:ext cx="5486400" cy="2988033"/>
           </a:xfrm>
           <a:prstGeom prst="rect">
             <a:avLst/>

</xml_diff>